<commit_message>
Deck: instruments as a row of lit dots at the foot, nothing in the top-right corner
Rebuilt on the team's own file. The instrument icon no longer sits inside the
card: the five instruments now appear as a row of dots at the foot of every
slide, lit for the ones a policy uses (what used to be the main instrument plus
the secondary ones) and grey for the rest, with the target groups in small grey
type underneath. The instrument pill and the "Target:" line in the top-right
corner are gone, and the title and the description move left into the space the
icon leaves.

Carries over the team's cover with the OECD logo, their edits to the definition
slides, and their wording on the nine policy slides they had kept. The deck
covers all 29 policies again and ends with the blank template slide; the
summary tables stay out, as in their file.

Co-Authored-By: Claude Opus 5 <noreply@anthropic.com>
Claude-Session: https://claude.ai/code/session_01REVwghctKjYh8VQ919ThdA
</commit_message>
<xml_diff>
--- a/policies/Policy_slide_template.pptx
+++ b/policies/Policy_slide_template.pptx
@@ -504,9 +504,8 @@
               <a:rPr lang="en-US" dirty="0"/>
               <a:t>Blank policy slide, same layout as the deck. Replace every grey placeholder.
 Flag: delete the grey box and drop in a flag image of the same size (1.05 x 0.79 inches), then put a thin light border around it.
-Icon: delete the circle and paste the icon of the main instrument from any slide of the deck, or leave the circle empty.
-Instrument: Financial incentives, Information &amp; nudges, Support &amp; training, Flexible positions, Flexible re-certification.
-Target: any combination of Switchers, Leavers and Retired.
+Instrument dots: the five circles at the foot are, in order, Financial incentives, Information &amp; nudges, Support &amp; training, Flexible positions and Flexible re-certification. Copy a lit dot from any slide of the deck over the ones this policy uses, and leave the others grey.
+Target groups: the grey line under the dots. Any combination of Switchers, Leavers and Retired.
 Scale: Large for a national policy, Medium for a state, region, province or canton, Small for a district, a city or a single institution. Colours: Large 1F4E46, Medium C8892B, Small B3542E.
 Fonts: Cambria for the title, Calibri for everything else. Text colours: 24313A and B3542E.</a:t>
             </a:r>
@@ -1031,111 +1030,6 @@
         </p:nvSpPr>
         <p:spPr>
           <a:xfrm>
-            <a:off x="8165592" y="384048"/>
-            <a:ext cx="3474720" cy="429768"/>
-          </a:xfrm>
-          <a:prstGeom prst="roundRect">
-            <a:avLst>
-              <a:gd name="adj" fmla="val 50000"/>
-            </a:avLst>
-          </a:prstGeom>
-          <a:solidFill>
-            <a:srgbClr val="EAF2EE"/>
-          </a:solidFill>
-          <a:ln w="12700">
-            <a:solidFill>
-              <a:srgbClr val="B3542E"/>
-            </a:solidFill>
-            <a:prstDash val="solid"/>
-          </a:ln>
-        </p:spPr>
-      </p:sp>
-      <p:sp>
-        <p:nvSpPr>
-          <p:cNvPr id="7" name="Text 5"/>
-          <p:cNvSpPr txBox="1"/>
-          <p:nvPr/>
-        </p:nvSpPr>
-        <p:spPr>
-          <a:xfrm>
-            <a:off x="8165592" y="384048"/>
-            <a:ext cx="3474720" cy="429768"/>
-          </a:xfrm>
-          <a:prstGeom prst="rect">
-            <a:avLst/>
-          </a:prstGeom>
-          <a:noFill/>
-          <a:ln/>
-        </p:spPr>
-        <p:txBody>
-          <a:bodyPr wrap="square" lIns="0" tIns="0" rIns="0" bIns="0" rtlCol="0" anchor="ctr"/>
-          <a:lstStyle/>
-          <a:p>
-            <a:pPr algn="ctr" indent="0" marL="0">
-              <a:buNone/>
-            </a:pPr>
-            <a:r>
-              <a:rPr lang="en-US" sz="1350" b="1" dirty="0">
-                <a:solidFill>
-                  <a:srgbClr val="B3542E"/>
-                </a:solidFill>
-                <a:latin typeface="Calibri" pitchFamily="34" charset="0"/>
-                <a:ea typeface="Calibri" pitchFamily="34" charset="-122"/>
-                <a:cs typeface="Calibri" pitchFamily="34" charset="-120"/>
-              </a:rPr>
-              <a:t>Main instrument</a:t>
-            </a:r>
-            <a:endParaRPr lang="en-US" sz="1350" dirty="0"/>
-          </a:p>
-        </p:txBody>
-      </p:sp>
-      <p:sp>
-        <p:nvSpPr>
-          <p:cNvPr id="8" name="Text 6"/>
-          <p:cNvSpPr txBox="1"/>
-          <p:nvPr/>
-        </p:nvSpPr>
-        <p:spPr>
-          <a:xfrm>
-            <a:off x="7251192" y="850392"/>
-            <a:ext cx="4389120" cy="274320"/>
-          </a:xfrm>
-          <a:prstGeom prst="rect">
-            <a:avLst/>
-          </a:prstGeom>
-          <a:noFill/>
-          <a:ln/>
-        </p:spPr>
-        <p:txBody>
-          <a:bodyPr wrap="square" lIns="0" tIns="0" rIns="0" bIns="0" rtlCol="0" anchor="t"/>
-          <a:lstStyle/>
-          <a:p>
-            <a:pPr algn="r" indent="0" marL="0">
-              <a:buNone/>
-            </a:pPr>
-            <a:r>
-              <a:rPr lang="en-US" sz="1100" dirty="0">
-                <a:solidFill>
-                  <a:srgbClr val="8C9B95"/>
-                </a:solidFill>
-                <a:latin typeface="Calibri" pitchFamily="34" charset="0"/>
-                <a:ea typeface="Calibri" pitchFamily="34" charset="-122"/>
-                <a:cs typeface="Calibri" pitchFamily="34" charset="-120"/>
-              </a:rPr>
-              <a:t>Target: Switchers / Leavers / Retired</a:t>
-            </a:r>
-            <a:endParaRPr lang="en-US" sz="1100" dirty="0"/>
-          </a:p>
-        </p:txBody>
-      </p:sp>
-      <p:sp>
-        <p:nvSpPr>
-          <p:cNvPr id="9" name="Shape 7"/>
-          <p:cNvSpPr/>
-          <p:nvPr/>
-        </p:nvSpPr>
-        <p:spPr>
-          <a:xfrm>
             <a:off x="457200" y="1371600"/>
             <a:ext cx="11274552" cy="3858768"/>
           </a:xfrm>
@@ -1157,78 +1051,14 @@
       </p:sp>
       <p:sp>
         <p:nvSpPr>
-          <p:cNvPr id="10" name="Shape 8"/>
-          <p:cNvSpPr/>
-          <p:nvPr/>
-        </p:nvSpPr>
-        <p:spPr>
-          <a:xfrm>
-            <a:off x="777240" y="1691640"/>
-            <a:ext cx="777240" cy="777240"/>
-          </a:xfrm>
-          <a:prstGeom prst="ellipse">
-            <a:avLst/>
-          </a:prstGeom>
-          <a:solidFill>
-            <a:srgbClr val="FFFFFF"/>
-          </a:solidFill>
-          <a:ln w="15875">
-            <a:solidFill>
-              <a:srgbClr val="1F4E46"/>
-            </a:solidFill>
-            <a:prstDash val="solid"/>
-          </a:ln>
-        </p:spPr>
-      </p:sp>
-      <p:sp>
-        <p:nvSpPr>
-          <p:cNvPr id="11" name="Text 9"/>
+          <p:cNvPr id="7" name="Text 5"/>
           <p:cNvSpPr txBox="1"/>
           <p:nvPr/>
         </p:nvSpPr>
         <p:spPr>
           <a:xfrm>
-            <a:off x="777240" y="1691640"/>
-            <a:ext cx="777240" cy="777240"/>
-          </a:xfrm>
-          <a:prstGeom prst="rect">
-            <a:avLst/>
-          </a:prstGeom>
-          <a:noFill/>
-          <a:ln/>
-        </p:spPr>
-        <p:txBody>
-          <a:bodyPr wrap="square" lIns="0" tIns="0" rIns="0" bIns="0" rtlCol="0" anchor="ctr"/>
-          <a:lstStyle/>
-          <a:p>
-            <a:pPr algn="ctr" indent="0" marL="0">
-              <a:buNone/>
-            </a:pPr>
-            <a:r>
-              <a:rPr lang="en-US" sz="900" dirty="0">
-                <a:solidFill>
-                  <a:srgbClr val="8C9B95"/>
-                </a:solidFill>
-                <a:latin typeface="Calibri" pitchFamily="34" charset="0"/>
-                <a:ea typeface="Calibri" pitchFamily="34" charset="-122"/>
-                <a:cs typeface="Calibri" pitchFamily="34" charset="-120"/>
-              </a:rPr>
-              <a:t>icon</a:t>
-            </a:r>
-            <a:endParaRPr lang="en-US" sz="900" dirty="0"/>
-          </a:p>
-        </p:txBody>
-      </p:sp>
-      <p:sp>
-        <p:nvSpPr>
-          <p:cNvPr id="12" name="Text 10"/>
-          <p:cNvSpPr txBox="1"/>
-          <p:nvPr/>
-        </p:nvSpPr>
-        <p:spPr>
-          <a:xfrm>
-            <a:off x="1783080" y="1536192"/>
-            <a:ext cx="9738360" cy="868680"/>
+            <a:off x="868680" y="1554480"/>
+            <a:ext cx="10451592" cy="822960"/>
           </a:xfrm>
           <a:prstGeom prst="rect">
             <a:avLst/>
@@ -1260,14 +1090,14 @@
       </p:sp>
       <p:sp>
         <p:nvSpPr>
-          <p:cNvPr id="13" name="Text 11"/>
+          <p:cNvPr id="8" name="Text 6"/>
           <p:cNvSpPr txBox="1"/>
           <p:nvPr/>
         </p:nvSpPr>
         <p:spPr>
           <a:xfrm>
-            <a:off x="1783080" y="2395728"/>
-            <a:ext cx="9738360" cy="2450592"/>
+            <a:off x="868680" y="2414016"/>
+            <a:ext cx="10451592" cy="2606040"/>
           </a:xfrm>
           <a:prstGeom prst="rect">
             <a:avLst/>
@@ -1302,67 +1132,14 @@
       </p:sp>
       <p:sp>
         <p:nvSpPr>
-          <p:cNvPr id="14" name="Text 12"/>
+          <p:cNvPr id="9" name="Text 7"/>
           <p:cNvSpPr txBox="1"/>
           <p:nvPr/>
         </p:nvSpPr>
         <p:spPr>
           <a:xfrm>
-            <a:off x="1783080" y="4864608"/>
-            <a:ext cx="9738360" cy="274320"/>
-          </a:xfrm>
-          <a:prstGeom prst="rect">
-            <a:avLst/>
-          </a:prstGeom>
-          <a:noFill/>
-          <a:ln/>
-        </p:spPr>
-        <p:txBody>
-          <a:bodyPr wrap="square" lIns="0" tIns="0" rIns="0" bIns="0" rtlCol="0" anchor="ctr"/>
-          <a:lstStyle/>
-          <a:p>
-            <a:pPr indent="0" marL="0">
-              <a:buNone/>
-            </a:pPr>
-            <a:r>
-              <a:rPr lang="en-US" sz="1150" b="1" dirty="0">
-                <a:solidFill>
-                  <a:srgbClr val="24313A"/>
-                </a:solidFill>
-                <a:latin typeface="Calibri" pitchFamily="34" charset="0"/>
-                <a:ea typeface="Calibri" pitchFamily="34" charset="-122"/>
-                <a:cs typeface="Calibri" pitchFamily="34" charset="-120"/>
-              </a:rPr>
-              <a:t>Secondary instruments: </a:t>
-            </a:r>
-            <a:pPr indent="0" marL="0">
-              <a:buNone/>
-            </a:pPr>
-            <a:r>
-              <a:rPr lang="en-US" sz="1150" dirty="0">
-                <a:solidFill>
-                  <a:srgbClr val="8C9B95"/>
-                </a:solidFill>
-                <a:latin typeface="Calibri" pitchFamily="34" charset="0"/>
-                <a:ea typeface="Calibri" pitchFamily="34" charset="-122"/>
-                <a:cs typeface="Calibri" pitchFamily="34" charset="-120"/>
-              </a:rPr>
-              <a:t>list them with commas, or write none</a:t>
-            </a:r>
-            <a:endParaRPr lang="en-US" sz="1150" dirty="0"/>
-          </a:p>
-        </p:txBody>
-      </p:sp>
-      <p:sp>
-        <p:nvSpPr>
-          <p:cNvPr id="15" name="Text 13"/>
-          <p:cNvSpPr txBox="1"/>
-          <p:nvPr/>
-        </p:nvSpPr>
-        <p:spPr>
-          <a:xfrm>
-            <a:off x="457200" y="5413248"/>
-            <a:ext cx="9692640" cy="868680"/>
+            <a:off x="457200" y="5303520"/>
+            <a:ext cx="11274552" cy="566928"/>
           </a:xfrm>
           <a:prstGeom prst="rect">
             <a:avLst/>
@@ -1408,7 +1185,366 @@
       </p:sp>
       <p:sp>
         <p:nvSpPr>
+          <p:cNvPr id="10" name="Shape 8"/>
+          <p:cNvSpPr/>
+          <p:nvPr/>
+        </p:nvSpPr>
+        <p:spPr>
+          <a:xfrm>
+            <a:off x="502920" y="5961888"/>
+            <a:ext cx="384048" cy="384048"/>
+          </a:xfrm>
+          <a:prstGeom prst="ellipse">
+            <a:avLst/>
+          </a:prstGeom>
+          <a:solidFill>
+            <a:srgbClr val="DCE6E0"/>
+          </a:solidFill>
+          <a:ln w="12700">
+            <a:solidFill>
+              <a:srgbClr val="DCE6E0"/>
+            </a:solidFill>
+            <a:prstDash val="solid"/>
+          </a:ln>
+        </p:spPr>
+      </p:sp>
+      <p:sp>
+        <p:nvSpPr>
+          <p:cNvPr id="11" name="Text 9"/>
+          <p:cNvSpPr txBox="1"/>
+          <p:nvPr/>
+        </p:nvSpPr>
+        <p:spPr>
+          <a:xfrm>
+            <a:off x="502920" y="5961888"/>
+            <a:ext cx="384048" cy="384048"/>
+          </a:xfrm>
+          <a:prstGeom prst="rect">
+            <a:avLst/>
+          </a:prstGeom>
+          <a:noFill/>
+          <a:ln/>
+        </p:spPr>
+        <p:txBody>
+          <a:bodyPr wrap="square" lIns="0" tIns="0" rIns="0" bIns="0" rtlCol="0" anchor="ctr"/>
+          <a:lstStyle/>
+          <a:p>
+            <a:pPr algn="ctr" indent="0" marL="0">
+              <a:buNone/>
+            </a:pPr>
+            <a:r>
+              <a:rPr lang="en-US" sz="900" dirty="0">
+                <a:solidFill>
+                  <a:srgbClr val="8C9B95"/>
+                </a:solidFill>
+                <a:latin typeface="Calibri" pitchFamily="34" charset="0"/>
+                <a:ea typeface="Calibri" pitchFamily="34" charset="-122"/>
+                <a:cs typeface="Calibri" pitchFamily="34" charset="-120"/>
+              </a:rPr>
+              <a:t>1</a:t>
+            </a:r>
+            <a:endParaRPr lang="en-US" sz="900" dirty="0"/>
+          </a:p>
+        </p:txBody>
+      </p:sp>
+      <p:sp>
+        <p:nvSpPr>
+          <p:cNvPr id="12" name="Shape 10"/>
+          <p:cNvSpPr/>
+          <p:nvPr/>
+        </p:nvSpPr>
+        <p:spPr>
+          <a:xfrm>
+            <a:off x="1042416" y="5961888"/>
+            <a:ext cx="384048" cy="384048"/>
+          </a:xfrm>
+          <a:prstGeom prst="ellipse">
+            <a:avLst/>
+          </a:prstGeom>
+          <a:solidFill>
+            <a:srgbClr val="DCE6E0"/>
+          </a:solidFill>
+          <a:ln w="12700">
+            <a:solidFill>
+              <a:srgbClr val="DCE6E0"/>
+            </a:solidFill>
+            <a:prstDash val="solid"/>
+          </a:ln>
+        </p:spPr>
+      </p:sp>
+      <p:sp>
+        <p:nvSpPr>
+          <p:cNvPr id="13" name="Text 11"/>
+          <p:cNvSpPr txBox="1"/>
+          <p:nvPr/>
+        </p:nvSpPr>
+        <p:spPr>
+          <a:xfrm>
+            <a:off x="1042416" y="5961888"/>
+            <a:ext cx="384048" cy="384048"/>
+          </a:xfrm>
+          <a:prstGeom prst="rect">
+            <a:avLst/>
+          </a:prstGeom>
+          <a:noFill/>
+          <a:ln/>
+        </p:spPr>
+        <p:txBody>
+          <a:bodyPr wrap="square" lIns="0" tIns="0" rIns="0" bIns="0" rtlCol="0" anchor="ctr"/>
+          <a:lstStyle/>
+          <a:p>
+            <a:pPr algn="ctr" indent="0" marL="0">
+              <a:buNone/>
+            </a:pPr>
+            <a:r>
+              <a:rPr lang="en-US" sz="900" dirty="0">
+                <a:solidFill>
+                  <a:srgbClr val="8C9B95"/>
+                </a:solidFill>
+                <a:latin typeface="Calibri" pitchFamily="34" charset="0"/>
+                <a:ea typeface="Calibri" pitchFamily="34" charset="-122"/>
+                <a:cs typeface="Calibri" pitchFamily="34" charset="-120"/>
+              </a:rPr>
+              <a:t>2</a:t>
+            </a:r>
+            <a:endParaRPr lang="en-US" sz="900" dirty="0"/>
+          </a:p>
+        </p:txBody>
+      </p:sp>
+      <p:sp>
+        <p:nvSpPr>
+          <p:cNvPr id="14" name="Shape 12"/>
+          <p:cNvSpPr/>
+          <p:nvPr/>
+        </p:nvSpPr>
+        <p:spPr>
+          <a:xfrm>
+            <a:off x="1581912" y="5961888"/>
+            <a:ext cx="384048" cy="384048"/>
+          </a:xfrm>
+          <a:prstGeom prst="ellipse">
+            <a:avLst/>
+          </a:prstGeom>
+          <a:solidFill>
+            <a:srgbClr val="DCE6E0"/>
+          </a:solidFill>
+          <a:ln w="12700">
+            <a:solidFill>
+              <a:srgbClr val="DCE6E0"/>
+            </a:solidFill>
+            <a:prstDash val="solid"/>
+          </a:ln>
+        </p:spPr>
+      </p:sp>
+      <p:sp>
+        <p:nvSpPr>
+          <p:cNvPr id="15" name="Text 13"/>
+          <p:cNvSpPr txBox="1"/>
+          <p:nvPr/>
+        </p:nvSpPr>
+        <p:spPr>
+          <a:xfrm>
+            <a:off x="1581912" y="5961888"/>
+            <a:ext cx="384048" cy="384048"/>
+          </a:xfrm>
+          <a:prstGeom prst="rect">
+            <a:avLst/>
+          </a:prstGeom>
+          <a:noFill/>
+          <a:ln/>
+        </p:spPr>
+        <p:txBody>
+          <a:bodyPr wrap="square" lIns="0" tIns="0" rIns="0" bIns="0" rtlCol="0" anchor="ctr"/>
+          <a:lstStyle/>
+          <a:p>
+            <a:pPr algn="ctr" indent="0" marL="0">
+              <a:buNone/>
+            </a:pPr>
+            <a:r>
+              <a:rPr lang="en-US" sz="900" dirty="0">
+                <a:solidFill>
+                  <a:srgbClr val="8C9B95"/>
+                </a:solidFill>
+                <a:latin typeface="Calibri" pitchFamily="34" charset="0"/>
+                <a:ea typeface="Calibri" pitchFamily="34" charset="-122"/>
+                <a:cs typeface="Calibri" pitchFamily="34" charset="-120"/>
+              </a:rPr>
+              <a:t>3</a:t>
+            </a:r>
+            <a:endParaRPr lang="en-US" sz="900" dirty="0"/>
+          </a:p>
+        </p:txBody>
+      </p:sp>
+      <p:sp>
+        <p:nvSpPr>
           <p:cNvPr id="16" name="Shape 14"/>
+          <p:cNvSpPr/>
+          <p:nvPr/>
+        </p:nvSpPr>
+        <p:spPr>
+          <a:xfrm>
+            <a:off x="2121408" y="5961888"/>
+            <a:ext cx="384048" cy="384048"/>
+          </a:xfrm>
+          <a:prstGeom prst="ellipse">
+            <a:avLst/>
+          </a:prstGeom>
+          <a:solidFill>
+            <a:srgbClr val="DCE6E0"/>
+          </a:solidFill>
+          <a:ln w="12700">
+            <a:solidFill>
+              <a:srgbClr val="DCE6E0"/>
+            </a:solidFill>
+            <a:prstDash val="solid"/>
+          </a:ln>
+        </p:spPr>
+      </p:sp>
+      <p:sp>
+        <p:nvSpPr>
+          <p:cNvPr id="17" name="Text 15"/>
+          <p:cNvSpPr txBox="1"/>
+          <p:nvPr/>
+        </p:nvSpPr>
+        <p:spPr>
+          <a:xfrm>
+            <a:off x="2121408" y="5961888"/>
+            <a:ext cx="384048" cy="384048"/>
+          </a:xfrm>
+          <a:prstGeom prst="rect">
+            <a:avLst/>
+          </a:prstGeom>
+          <a:noFill/>
+          <a:ln/>
+        </p:spPr>
+        <p:txBody>
+          <a:bodyPr wrap="square" lIns="0" tIns="0" rIns="0" bIns="0" rtlCol="0" anchor="ctr"/>
+          <a:lstStyle/>
+          <a:p>
+            <a:pPr algn="ctr" indent="0" marL="0">
+              <a:buNone/>
+            </a:pPr>
+            <a:r>
+              <a:rPr lang="en-US" sz="900" dirty="0">
+                <a:solidFill>
+                  <a:srgbClr val="8C9B95"/>
+                </a:solidFill>
+                <a:latin typeface="Calibri" pitchFamily="34" charset="0"/>
+                <a:ea typeface="Calibri" pitchFamily="34" charset="-122"/>
+                <a:cs typeface="Calibri" pitchFamily="34" charset="-120"/>
+              </a:rPr>
+              <a:t>4</a:t>
+            </a:r>
+            <a:endParaRPr lang="en-US" sz="900" dirty="0"/>
+          </a:p>
+        </p:txBody>
+      </p:sp>
+      <p:sp>
+        <p:nvSpPr>
+          <p:cNvPr id="18" name="Shape 16"/>
+          <p:cNvSpPr/>
+          <p:nvPr/>
+        </p:nvSpPr>
+        <p:spPr>
+          <a:xfrm>
+            <a:off x="2660904" y="5961888"/>
+            <a:ext cx="384048" cy="384048"/>
+          </a:xfrm>
+          <a:prstGeom prst="ellipse">
+            <a:avLst/>
+          </a:prstGeom>
+          <a:solidFill>
+            <a:srgbClr val="DCE6E0"/>
+          </a:solidFill>
+          <a:ln w="12700">
+            <a:solidFill>
+              <a:srgbClr val="DCE6E0"/>
+            </a:solidFill>
+            <a:prstDash val="solid"/>
+          </a:ln>
+        </p:spPr>
+      </p:sp>
+      <p:sp>
+        <p:nvSpPr>
+          <p:cNvPr id="19" name="Text 17"/>
+          <p:cNvSpPr txBox="1"/>
+          <p:nvPr/>
+        </p:nvSpPr>
+        <p:spPr>
+          <a:xfrm>
+            <a:off x="2660904" y="5961888"/>
+            <a:ext cx="384048" cy="384048"/>
+          </a:xfrm>
+          <a:prstGeom prst="rect">
+            <a:avLst/>
+          </a:prstGeom>
+          <a:noFill/>
+          <a:ln/>
+        </p:spPr>
+        <p:txBody>
+          <a:bodyPr wrap="square" lIns="0" tIns="0" rIns="0" bIns="0" rtlCol="0" anchor="ctr"/>
+          <a:lstStyle/>
+          <a:p>
+            <a:pPr algn="ctr" indent="0" marL="0">
+              <a:buNone/>
+            </a:pPr>
+            <a:r>
+              <a:rPr lang="en-US" sz="900" dirty="0">
+                <a:solidFill>
+                  <a:srgbClr val="8C9B95"/>
+                </a:solidFill>
+                <a:latin typeface="Calibri" pitchFamily="34" charset="0"/>
+                <a:ea typeface="Calibri" pitchFamily="34" charset="-122"/>
+                <a:cs typeface="Calibri" pitchFamily="34" charset="-120"/>
+              </a:rPr>
+              <a:t>5</a:t>
+            </a:r>
+            <a:endParaRPr lang="en-US" sz="900" dirty="0"/>
+          </a:p>
+        </p:txBody>
+      </p:sp>
+      <p:sp>
+        <p:nvSpPr>
+          <p:cNvPr id="20" name="Text 18"/>
+          <p:cNvSpPr txBox="1"/>
+          <p:nvPr/>
+        </p:nvSpPr>
+        <p:spPr>
+          <a:xfrm>
+            <a:off x="502920" y="6419088"/>
+            <a:ext cx="4572000" cy="256032"/>
+          </a:xfrm>
+          <a:prstGeom prst="rect">
+            <a:avLst/>
+          </a:prstGeom>
+          <a:noFill/>
+          <a:ln/>
+        </p:spPr>
+        <p:txBody>
+          <a:bodyPr wrap="square" lIns="0" tIns="0" rIns="0" bIns="0" rtlCol="0" anchor="ctr"/>
+          <a:lstStyle/>
+          <a:p>
+            <a:pPr indent="0" marL="0">
+              <a:buNone/>
+            </a:pPr>
+            <a:r>
+              <a:rPr lang="en-US" sz="1050" dirty="0">
+                <a:solidFill>
+                  <a:srgbClr val="8C9B95"/>
+                </a:solidFill>
+                <a:latin typeface="Calibri" pitchFamily="34" charset="0"/>
+                <a:ea typeface="Calibri" pitchFamily="34" charset="-122"/>
+                <a:cs typeface="Calibri" pitchFamily="34" charset="-120"/>
+              </a:rPr>
+              <a:t>Switchers / Leavers / Retired</a:t>
+            </a:r>
+            <a:endParaRPr lang="en-US" sz="1050" dirty="0"/>
+          </a:p>
+        </p:txBody>
+      </p:sp>
+      <p:sp>
+        <p:nvSpPr>
+          <p:cNvPr id="21" name="Shape 19"/>
           <p:cNvSpPr/>
           <p:nvPr/>
         </p:nvSpPr>
@@ -1435,7 +1571,7 @@
       </p:sp>
       <p:sp>
         <p:nvSpPr>
-          <p:cNvPr id="17" name="Text 15"/>
+          <p:cNvPr id="22" name="Text 20"/>
           <p:cNvSpPr txBox="1"/>
           <p:nvPr/>
         </p:nvSpPr>
@@ -1474,7 +1610,7 @@
       </p:sp>
       <p:sp>
         <p:nvSpPr>
-          <p:cNvPr id="18" name="Text 16"/>
+          <p:cNvPr id="23" name="Text 21"/>
           <p:cNvSpPr txBox="1"/>
           <p:nvPr/>
         </p:nvSpPr>

</xml_diff>

<commit_message>
Deck: scale label to the top right, instrument dots to the bottom right, linked index
The five instrument dots move to the bottom-right corner and get bigger, with
the target groups right-aligned underneath them; the scale label takes the
top-right corner the instrument pill used to occupy. The definition slides get
their circles back in the colour the team had set on them. Slide numbers move to
the bottom left, out of the way of the dots.

Two index slides close the deck: every policy with its target groups and scale,
and the policy name hyperlinked to its own slide. The blank template follows the
same layout.

Also adds the six interview scripts as one Word document with a clickable
contents page, built from the same markdown.

Co-Authored-By: Claude Opus 5 <noreply@anthropic.com>
Claude-Session: https://claude.ai/code/session_01REVwghctKjYh8VQ919ThdA
</commit_message>
<xml_diff>
--- a/policies/Policy_slide_template.pptx
+++ b/policies/Policy_slide_template.pptx
@@ -952,8 +952,8 @@
         </p:nvSpPr>
         <p:spPr>
           <a:xfrm>
-            <a:off x="1600200" y="329184"/>
-            <a:ext cx="6217920" cy="457200"/>
+            <a:off x="1600200" y="384048"/>
+            <a:ext cx="8321040" cy="457200"/>
           </a:xfrm>
           <a:prstGeom prst="rect">
             <a:avLst/>
@@ -991,8 +991,8 @@
         </p:nvSpPr>
         <p:spPr>
           <a:xfrm>
-            <a:off x="1600200" y="786384"/>
-            <a:ext cx="6217920" cy="310896"/>
+            <a:off x="1600200" y="841248"/>
+            <a:ext cx="8321040" cy="310896"/>
           </a:xfrm>
           <a:prstGeom prst="rect">
             <a:avLst/>
@@ -1139,7 +1139,7 @@
         <p:spPr>
           <a:xfrm>
             <a:off x="457200" y="5303520"/>
-            <a:ext cx="11274552" cy="566928"/>
+            <a:ext cx="8138160" cy="822960"/>
           </a:xfrm>
           <a:prstGeom prst="rect">
             <a:avLst/>
@@ -1191,8 +1191,8 @@
         </p:nvSpPr>
         <p:spPr>
           <a:xfrm>
-            <a:off x="502920" y="5961888"/>
-            <a:ext cx="384048" cy="384048"/>
+            <a:off x="8695944" y="5815584"/>
+            <a:ext cx="475488" cy="475488"/>
           </a:xfrm>
           <a:prstGeom prst="ellipse">
             <a:avLst/>
@@ -1216,8 +1216,8 @@
         </p:nvSpPr>
         <p:spPr>
           <a:xfrm>
-            <a:off x="502920" y="5961888"/>
-            <a:ext cx="384048" cy="384048"/>
+            <a:off x="8695944" y="5815584"/>
+            <a:ext cx="475488" cy="475488"/>
           </a:xfrm>
           <a:prstGeom prst="rect">
             <a:avLst/>
@@ -1233,7 +1233,7 @@
               <a:buNone/>
             </a:pPr>
             <a:r>
-              <a:rPr lang="en-US" sz="900" dirty="0">
+              <a:rPr lang="en-US" sz="1000" dirty="0">
                 <a:solidFill>
                   <a:srgbClr val="8C9B95"/>
                 </a:solidFill>
@@ -1243,7 +1243,7 @@
               </a:rPr>
               <a:t>1</a:t>
             </a:r>
-            <a:endParaRPr lang="en-US" sz="900" dirty="0"/>
+            <a:endParaRPr lang="en-US" sz="1000" dirty="0"/>
           </a:p>
         </p:txBody>
       </p:sp>
@@ -1255,8 +1255,8 @@
         </p:nvSpPr>
         <p:spPr>
           <a:xfrm>
-            <a:off x="1042416" y="5961888"/>
-            <a:ext cx="384048" cy="384048"/>
+            <a:off x="9336024" y="5815584"/>
+            <a:ext cx="475488" cy="475488"/>
           </a:xfrm>
           <a:prstGeom prst="ellipse">
             <a:avLst/>
@@ -1280,8 +1280,8 @@
         </p:nvSpPr>
         <p:spPr>
           <a:xfrm>
-            <a:off x="1042416" y="5961888"/>
-            <a:ext cx="384048" cy="384048"/>
+            <a:off x="9336024" y="5815584"/>
+            <a:ext cx="475488" cy="475488"/>
           </a:xfrm>
           <a:prstGeom prst="rect">
             <a:avLst/>
@@ -1297,7 +1297,7 @@
               <a:buNone/>
             </a:pPr>
             <a:r>
-              <a:rPr lang="en-US" sz="900" dirty="0">
+              <a:rPr lang="en-US" sz="1000" dirty="0">
                 <a:solidFill>
                   <a:srgbClr val="8C9B95"/>
                 </a:solidFill>
@@ -1307,7 +1307,7 @@
               </a:rPr>
               <a:t>2</a:t>
             </a:r>
-            <a:endParaRPr lang="en-US" sz="900" dirty="0"/>
+            <a:endParaRPr lang="en-US" sz="1000" dirty="0"/>
           </a:p>
         </p:txBody>
       </p:sp>
@@ -1319,8 +1319,8 @@
         </p:nvSpPr>
         <p:spPr>
           <a:xfrm>
-            <a:off x="1581912" y="5961888"/>
-            <a:ext cx="384048" cy="384048"/>
+            <a:off x="9976104" y="5815584"/>
+            <a:ext cx="475488" cy="475488"/>
           </a:xfrm>
           <a:prstGeom prst="ellipse">
             <a:avLst/>
@@ -1344,8 +1344,8 @@
         </p:nvSpPr>
         <p:spPr>
           <a:xfrm>
-            <a:off x="1581912" y="5961888"/>
-            <a:ext cx="384048" cy="384048"/>
+            <a:off x="9976104" y="5815584"/>
+            <a:ext cx="475488" cy="475488"/>
           </a:xfrm>
           <a:prstGeom prst="rect">
             <a:avLst/>
@@ -1361,7 +1361,7 @@
               <a:buNone/>
             </a:pPr>
             <a:r>
-              <a:rPr lang="en-US" sz="900" dirty="0">
+              <a:rPr lang="en-US" sz="1000" dirty="0">
                 <a:solidFill>
                   <a:srgbClr val="8C9B95"/>
                 </a:solidFill>
@@ -1371,7 +1371,7 @@
               </a:rPr>
               <a:t>3</a:t>
             </a:r>
-            <a:endParaRPr lang="en-US" sz="900" dirty="0"/>
+            <a:endParaRPr lang="en-US" sz="1000" dirty="0"/>
           </a:p>
         </p:txBody>
       </p:sp>
@@ -1383,8 +1383,8 @@
         </p:nvSpPr>
         <p:spPr>
           <a:xfrm>
-            <a:off x="2121408" y="5961888"/>
-            <a:ext cx="384048" cy="384048"/>
+            <a:off x="10616184" y="5815584"/>
+            <a:ext cx="475488" cy="475488"/>
           </a:xfrm>
           <a:prstGeom prst="ellipse">
             <a:avLst/>
@@ -1408,8 +1408,8 @@
         </p:nvSpPr>
         <p:spPr>
           <a:xfrm>
-            <a:off x="2121408" y="5961888"/>
-            <a:ext cx="384048" cy="384048"/>
+            <a:off x="10616184" y="5815584"/>
+            <a:ext cx="475488" cy="475488"/>
           </a:xfrm>
           <a:prstGeom prst="rect">
             <a:avLst/>
@@ -1425,7 +1425,7 @@
               <a:buNone/>
             </a:pPr>
             <a:r>
-              <a:rPr lang="en-US" sz="900" dirty="0">
+              <a:rPr lang="en-US" sz="1000" dirty="0">
                 <a:solidFill>
                   <a:srgbClr val="8C9B95"/>
                 </a:solidFill>
@@ -1435,7 +1435,7 @@
               </a:rPr>
               <a:t>4</a:t>
             </a:r>
-            <a:endParaRPr lang="en-US" sz="900" dirty="0"/>
+            <a:endParaRPr lang="en-US" sz="1000" dirty="0"/>
           </a:p>
         </p:txBody>
       </p:sp>
@@ -1447,8 +1447,8 @@
         </p:nvSpPr>
         <p:spPr>
           <a:xfrm>
-            <a:off x="2660904" y="5961888"/>
-            <a:ext cx="384048" cy="384048"/>
+            <a:off x="11256264" y="5815584"/>
+            <a:ext cx="475488" cy="475488"/>
           </a:xfrm>
           <a:prstGeom prst="ellipse">
             <a:avLst/>
@@ -1472,8 +1472,8 @@
         </p:nvSpPr>
         <p:spPr>
           <a:xfrm>
-            <a:off x="2660904" y="5961888"/>
-            <a:ext cx="384048" cy="384048"/>
+            <a:off x="11256264" y="5815584"/>
+            <a:ext cx="475488" cy="475488"/>
           </a:xfrm>
           <a:prstGeom prst="rect">
             <a:avLst/>
@@ -1489,7 +1489,7 @@
               <a:buNone/>
             </a:pPr>
             <a:r>
-              <a:rPr lang="en-US" sz="900" dirty="0">
+              <a:rPr lang="en-US" sz="1000" dirty="0">
                 <a:solidFill>
                   <a:srgbClr val="8C9B95"/>
                 </a:solidFill>
@@ -1499,7 +1499,7 @@
               </a:rPr>
               <a:t>5</a:t>
             </a:r>
-            <a:endParaRPr lang="en-US" sz="900" dirty="0"/>
+            <a:endParaRPr lang="en-US" sz="1000" dirty="0"/>
           </a:p>
         </p:txBody>
       </p:sp>
@@ -1511,8 +1511,8 @@
         </p:nvSpPr>
         <p:spPr>
           <a:xfrm>
-            <a:off x="502920" y="6419088"/>
-            <a:ext cx="4572000" cy="256032"/>
+            <a:off x="7132320" y="6355080"/>
+            <a:ext cx="4599432" cy="256032"/>
           </a:xfrm>
           <a:prstGeom prst="rect">
             <a:avLst/>
@@ -1524,7 +1524,7 @@
           <a:bodyPr wrap="square" lIns="0" tIns="0" rIns="0" bIns="0" rtlCol="0" anchor="ctr"/>
           <a:lstStyle/>
           <a:p>
-            <a:pPr indent="0" marL="0">
+            <a:pPr algn="r" indent="0" marL="0">
               <a:buNone/>
             </a:pPr>
             <a:r>
@@ -1550,8 +1550,8 @@
         </p:nvSpPr>
         <p:spPr>
           <a:xfrm>
-            <a:off x="10451592" y="5943600"/>
-            <a:ext cx="1280160" cy="365760"/>
+            <a:off x="10085832" y="384048"/>
+            <a:ext cx="1645920" cy="429768"/>
           </a:xfrm>
           <a:prstGeom prst="roundRect">
             <a:avLst>
@@ -1577,8 +1577,8 @@
         </p:nvSpPr>
         <p:spPr>
           <a:xfrm>
-            <a:off x="10451592" y="5943600"/>
-            <a:ext cx="1280160" cy="365760"/>
+            <a:off x="10085832" y="384048"/>
+            <a:ext cx="1645920" cy="429768"/>
           </a:xfrm>
           <a:prstGeom prst="rect">
             <a:avLst/>
@@ -1594,7 +1594,7 @@
               <a:buNone/>
             </a:pPr>
             <a:r>
-              <a:rPr lang="en-US" sz="1250" b="1" dirty="0">
+              <a:rPr lang="en-US" sz="1400" b="1" dirty="0">
                 <a:solidFill>
                   <a:srgbClr val="FFFFFF"/>
                 </a:solidFill>
@@ -1604,7 +1604,7 @@
               </a:rPr>
               <a:t>Scale</a:t>
             </a:r>
-            <a:endParaRPr lang="en-US" sz="1250" dirty="0"/>
+            <a:endParaRPr lang="en-US" sz="1400" dirty="0"/>
           </a:p>
         </p:txBody>
       </p:sp>
@@ -1616,7 +1616,7 @@
         </p:nvSpPr>
         <p:spPr>
           <a:xfrm>
-            <a:off x="11185855" y="6473952"/>
+            <a:off x="457200" y="6473952"/>
             <a:ext cx="548640" cy="274320"/>
           </a:xfrm>
           <a:prstGeom prst="rect">
@@ -1629,7 +1629,7 @@
           <a:bodyPr wrap="square" lIns="0" tIns="0" rIns="0" bIns="0" rtlCol="0" anchor="ctr"/>
           <a:lstStyle/>
           <a:p>
-            <a:pPr algn="r" indent="0" marL="0">
+            <a:pPr algn="l" indent="0" marL="0">
               <a:buNone/>
             </a:pPr>
             <a:r>

</xml_diff>